<commit_message>
Trust deck: add live PE-gating proof (Partners Group, June 2026)
Add a dated, attributed callout on the 'when valuations crack' slide: Partners
Group capped redemptions in its $8.6bn evergreen PE fund at 5% of NAV after
requests hit 9.8%; KKR/Blackstone/Ares fell. Sharpen that slide's closer to the
liquidity contrast, and reference the event in the 'why a trust' liquidity
bullet. Real-time validation of the daily-liquidity advantage over illiquid PE.

https://claude.ai/code/session_01HQUpw4QYvApiNnSfGrjnJ2
</commit_message>
<xml_diff>
--- a/Athanase_Investment_Trust_Pitch.pptx
+++ b/Athanase_Investment_Trust_Pitch.pptx
@@ -16360,7 +16360,7 @@
                 </a:solidFill>
                 <a:latin typeface="Arial"/>
               </a:rPr>
-              <a:t>shares trade on the London Stock Exchange — an institutional strategy with daily dealing and no capital calls.</a:t>
+              <a:t>shares trade on the London Stock Exchange — daily dealing and no capital calls, while evergreen PE funds are gating redemptions (Partners Group, June 2026).</a:t>
             </a:r>
           </a:p>
           <a:p>
@@ -22505,7 +22505,7 @@
                 <a:spcPct val="118000"/>
               </a:lnSpc>
               <a:spcAft>
-                <a:spcPts val="1500"/>
+                <a:spcPts val="1400"/>
               </a:spcAft>
             </a:pPr>
             <a:r>
@@ -22533,7 +22533,7 @@
                 <a:spcPct val="118000"/>
               </a:lnSpc>
               <a:spcAft>
-                <a:spcPts val="1500"/>
+                <a:spcPts val="1400"/>
               </a:spcAft>
             </a:pPr>
             <a:r>
@@ -22561,7 +22561,7 @@
                 <a:spcPct val="118000"/>
               </a:lnSpc>
               <a:spcAft>
-                <a:spcPts val="1500"/>
+                <a:spcPts val="1400"/>
               </a:spcAft>
             </a:pPr>
             <a:r>
@@ -22593,8 +22593,52 @@
         </p:nvSpPr>
         <p:spPr>
           <a:xfrm>
-            <a:off x="438922" y="6300825"/>
-            <a:ext cx="8895505" cy="585216"/>
+            <a:off x="438922" y="5188915"/>
+            <a:ext cx="8895505" cy="936345"/>
+          </a:xfrm>
+          <a:prstGeom prst="rect">
+            <a:avLst/>
+          </a:prstGeom>
+          <a:solidFill>
+            <a:srgbClr val="F6F7F9"/>
+          </a:solidFill>
+          <a:ln>
+            <a:noFill/>
+          </a:ln>
+          <a:effectLst/>
+        </p:spPr>
+        <p:style>
+          <a:lnRef idx="1">
+            <a:schemeClr val="accent1"/>
+          </a:lnRef>
+          <a:fillRef idx="3">
+            <a:schemeClr val="accent1"/>
+          </a:fillRef>
+          <a:effectRef idx="2">
+            <a:schemeClr val="accent1"/>
+          </a:effectRef>
+          <a:fontRef idx="minor">
+            <a:schemeClr val="lt1"/>
+          </a:fontRef>
+        </p:style>
+        <p:txBody>
+          <a:bodyPr rtlCol="0" anchor="ctr"/>
+          <a:lstStyle/>
+          <a:p>
+            <a:pPr algn="ctr"/>
+          </a:p>
+        </p:txBody>
+      </p:sp>
+      <p:sp>
+        <p:nvSpPr>
+          <p:cNvPr id="11" name="Rectangle 10"/>
+          <p:cNvSpPr/>
+          <p:nvPr/>
+        </p:nvSpPr>
+        <p:spPr>
+          <a:xfrm>
+            <a:off x="438922" y="5188915"/>
+            <a:ext cx="58523" cy="936345"/>
           </a:xfrm>
           <a:prstGeom prst="rect">
             <a:avLst/>
@@ -22631,7 +22675,135 @@
       </p:sp>
       <p:sp>
         <p:nvSpPr>
-          <p:cNvPr id="11" name="TextBox 10"/>
+          <p:cNvPr id="12" name="TextBox 11"/>
+          <p:cNvSpPr txBox="1"/>
+          <p:nvPr/>
+        </p:nvSpPr>
+        <p:spPr>
+          <a:xfrm>
+            <a:off x="621807" y="5296204"/>
+            <a:ext cx="8485844" cy="292608"/>
+          </a:xfrm>
+          <a:prstGeom prst="rect">
+            <a:avLst/>
+          </a:prstGeom>
+          <a:noFill/>
+        </p:spPr>
+        <p:txBody>
+          <a:bodyPr wrap="square" anchor="t" lIns="0" rIns="0" tIns="0" bIns="0">
+            <a:spAutoFit/>
+          </a:bodyPr>
+          <a:lstStyle/>
+          <a:p>
+            <a:pPr algn="l">
+              <a:lnSpc>
+                <a:spcPct val="110000"/>
+              </a:lnSpc>
+              <a:spcAft>
+                <a:spcPts val="400"/>
+              </a:spcAft>
+            </a:pPr>
+            <a:r>
+              <a:rPr sz="760" b="1" i="0">
+                <a:solidFill>
+                  <a:srgbClr val="314359"/>
+                </a:solidFill>
+                <a:latin typeface="Arial"/>
+              </a:rPr>
+              <a:t>LIVE — JUNE 2026  ·  BLOOMBERG / CNBC</a:t>
+            </a:r>
+          </a:p>
+        </p:txBody>
+      </p:sp>
+      <p:sp>
+        <p:nvSpPr>
+          <p:cNvPr id="13" name="TextBox 12"/>
+          <p:cNvSpPr txBox="1"/>
+          <p:nvPr/>
+        </p:nvSpPr>
+        <p:spPr>
+          <a:xfrm>
+            <a:off x="621807" y="5579059"/>
+            <a:ext cx="8595575" cy="487680"/>
+          </a:xfrm>
+          <a:prstGeom prst="rect">
+            <a:avLst/>
+          </a:prstGeom>
+          <a:noFill/>
+        </p:spPr>
+        <p:txBody>
+          <a:bodyPr wrap="square" anchor="t" lIns="0" rIns="0" tIns="0" bIns="0">
+            <a:spAutoFit/>
+          </a:bodyPr>
+          <a:lstStyle/>
+          <a:p>
+            <a:pPr algn="l">
+              <a:lnSpc>
+                <a:spcPct val="116000"/>
+              </a:lnSpc>
+              <a:spcAft>
+                <a:spcPts val="0"/>
+              </a:spcAft>
+            </a:pPr>
+            <a:r>
+              <a:rPr sz="919" b="0" i="0">
+                <a:solidFill>
+                  <a:srgbClr val="0E1620"/>
+                </a:solidFill>
+                <a:latin typeface="Arial"/>
+              </a:rPr>
+              <a:t>Partners Group capped redemptions in its $8.6bn evergreen private-equity fund at 5% of NAV after withdrawal requests hit 9.8% — KKR, Blackstone and Ares fell on the news. The PE exit is closing, exactly as feared.</a:t>
+            </a:r>
+          </a:p>
+        </p:txBody>
+      </p:sp>
+      <p:sp>
+        <p:nvSpPr>
+          <p:cNvPr id="14" name="Rectangle 13"/>
+          <p:cNvSpPr/>
+          <p:nvPr/>
+        </p:nvSpPr>
+        <p:spPr>
+          <a:xfrm>
+            <a:off x="438922" y="6300825"/>
+            <a:ext cx="8895505" cy="585216"/>
+          </a:xfrm>
+          <a:prstGeom prst="rect">
+            <a:avLst/>
+          </a:prstGeom>
+          <a:solidFill>
+            <a:srgbClr val="152130"/>
+          </a:solidFill>
+          <a:ln>
+            <a:noFill/>
+          </a:ln>
+          <a:effectLst/>
+        </p:spPr>
+        <p:style>
+          <a:lnRef idx="1">
+            <a:schemeClr val="accent1"/>
+          </a:lnRef>
+          <a:fillRef idx="3">
+            <a:schemeClr val="accent1"/>
+          </a:fillRef>
+          <a:effectRef idx="2">
+            <a:schemeClr val="accent1"/>
+          </a:effectRef>
+          <a:fontRef idx="minor">
+            <a:schemeClr val="lt1"/>
+          </a:fontRef>
+        </p:style>
+        <p:txBody>
+          <a:bodyPr rtlCol="0" anchor="ctr"/>
+          <a:lstStyle/>
+          <a:p>
+            <a:pPr algn="ctr"/>
+          </a:p>
+        </p:txBody>
+      </p:sp>
+      <p:sp>
+        <p:nvSpPr>
+          <p:cNvPr id="15" name="TextBox 14"/>
           <p:cNvSpPr txBox="1"/>
           <p:nvPr/>
         </p:nvSpPr>
@@ -22666,7 +22838,7 @@
                 </a:solidFill>
                 <a:latin typeface="Arial"/>
               </a:rPr>
-              <a:t>The time to own a liquid, low-correlation hedge is while markets are still expensive.</a:t>
+              <a:t>While evergreen PE gates redemptions, a listed trust trades every day the market is open — the liquidity your clients keep when it matters.</a:t>
             </a:r>
           </a:p>
         </p:txBody>

</xml_diff>